<commit_message>
Verify demo in CI and align presentation links with captured transactions
</commit_message>
<xml_diff>
--- a/demo-site/dist/pitch.pptx
+++ b/demo-site/dist/pitch.pptx
@@ -5231,7 +5231,7 @@
               </a:defRPr>
             </a:pPr>
             <a:r>
-              <a:t>USDC allocation read from devnet at 2026-10-11T09:40:11.849Z.</a:t>
+              <a:t>USDC allocation read from devnet at 2026-10-11T09:29:57.938Z.</a:t>
             </a:r>
           </a:p>
         </p:txBody>
@@ -11491,7 +11491,7 @@
               </a:defRPr>
             </a:pPr>
             <a:r>
-              <a:t>Published round 509859720</a:t>
+              <a:t>Published round 509857083</a:t>
             </a:r>
           </a:p>
         </p:txBody>
@@ -11569,7 +11569,7 @@
               </a:defRPr>
             </a:pPr>
             <a:r>
-              <a:t>Snapshot anchor slot 509859730</a:t>
+              <a:t>Snapshot anchor slot 509857093</a:t>
             </a:r>
           </a:p>
         </p:txBody>
@@ -11647,7 +11647,7 @@
               </a:defRPr>
             </a:pPr>
             <a:r>
-              <a:t>SHA-256 10d7df9c596ff35dc177da2f83d5c5ff717bb78680d940dbb8c39331812e98a9</a:t>
+              <a:t>SHA-256 ca09e6fc4332314130baec5d18f78ed82c2d99d060095d3a77ac6070f9c86486</a:t>
             </a:r>
           </a:p>
         </p:txBody>

</xml_diff>